<commit_message>
Update PowerPoint for song #135 in FUBC - Українські
</commit_message>
<xml_diff>
--- a/fubc-ua/135-Ти ради мене, Спасе (Пісні Спасенних №132).pptx
+++ b/fubc-ua/135-Ти ради мене, Спасе (Пісні Спасенних №132).pptx
@@ -1891,23 +1891,6 @@
             </a:r>
             <a:endParaRPr lang="en-US" sz="5200" dirty="0"/>
           </a:p>
-          <a:p>
-            <a:pPr algn="ctr" indent="0" marL="0">
-              <a:buNone/>
-            </a:pPr>
-            <a:r>
-              <a:rPr lang="en-US" sz="5200" b="1" dirty="0">
-                <a:solidFill>
-                  <a:srgbClr val="FFFFFF"/>
-                </a:solidFill>
-                <a:latin typeface="Arial" pitchFamily="34" charset="0"/>
-                <a:ea typeface="Arial" pitchFamily="34" charset="-122"/>
-                <a:cs typeface="Arial" pitchFamily="34" charset="-120"/>
-              </a:rPr>
-              <a:t>(Пісні Спасенних №132)</a:t>
-            </a:r>
-            <a:endParaRPr lang="en-US" sz="5200" dirty="0"/>
-          </a:p>
         </p:txBody>
       </p:sp>
     </p:spTree>
@@ -2097,7 +2080,7 @@
                 <a:ea typeface="Arial" pitchFamily="34" charset="-122"/>
                 <a:cs typeface="Arial" pitchFamily="34" charset="-120"/>
               </a:rPr>
-              <a:t>За мене Ти (о Ісусе любий),</a:t>
+              <a:t>За мене Ти,</a:t>
             </a:r>
             <a:endParaRPr lang="en-US" sz="5200" dirty="0"/>
           </a:p>
@@ -2131,7 +2114,7 @@
                 <a:ea typeface="Arial" pitchFamily="34" charset="-122"/>
                 <a:cs typeface="Arial" pitchFamily="34" charset="-120"/>
               </a:rPr>
-              <a:t>Слава Тобі (хай лунає всюди),</a:t>
+              <a:t>Слава Тобі,</a:t>
             </a:r>
             <a:endParaRPr lang="en-US" sz="5200" dirty="0"/>
           </a:p>
@@ -2412,7 +2395,7 @@
                 <a:ea typeface="Arial" pitchFamily="34" charset="-122"/>
                 <a:cs typeface="Arial" pitchFamily="34" charset="-120"/>
               </a:rPr>
-              <a:t>За мене Ти (о Ісусе любий),</a:t>
+              <a:t>За мене Ти,</a:t>
             </a:r>
             <a:endParaRPr lang="en-US" sz="5200" dirty="0"/>
           </a:p>
@@ -2446,7 +2429,7 @@
                 <a:ea typeface="Arial" pitchFamily="34" charset="-122"/>
                 <a:cs typeface="Arial" pitchFamily="34" charset="-120"/>
               </a:rPr>
-              <a:t>Слава Тобі (хай лунає всюди),</a:t>
+              <a:t>Слава Тобі,</a:t>
             </a:r>
             <a:endParaRPr lang="en-US" sz="5200" dirty="0"/>
           </a:p>
@@ -2656,7 +2639,7 @@
                 <a:ea typeface="Arial" pitchFamily="34" charset="-122"/>
                 <a:cs typeface="Arial" pitchFamily="34" charset="-120"/>
               </a:rPr>
-              <a:t>За мене Ти (о Ісусе любий),</a:t>
+              <a:t>За мене Ти,</a:t>
             </a:r>
             <a:endParaRPr lang="en-US" sz="5200" dirty="0"/>
           </a:p>
@@ -2690,7 +2673,7 @@
                 <a:ea typeface="Arial" pitchFamily="34" charset="-122"/>
                 <a:cs typeface="Arial" pitchFamily="34" charset="-120"/>
               </a:rPr>
-              <a:t>Слава Тобі (хай лунає всюди),</a:t>
+              <a:t>Слава Тобі,</a:t>
             </a:r>
             <a:endParaRPr lang="en-US" sz="5200" dirty="0"/>
           </a:p>
@@ -2900,7 +2883,7 @@
                 <a:ea typeface="Arial" pitchFamily="34" charset="-122"/>
                 <a:cs typeface="Arial" pitchFamily="34" charset="-120"/>
               </a:rPr>
-              <a:t>За мене Ти (о Ісусе любий),</a:t>
+              <a:t>За мене Ти,</a:t>
             </a:r>
             <a:endParaRPr lang="en-US" sz="5200" dirty="0"/>
           </a:p>
@@ -2934,7 +2917,7 @@
                 <a:ea typeface="Arial" pitchFamily="34" charset="-122"/>
                 <a:cs typeface="Arial" pitchFamily="34" charset="-120"/>
               </a:rPr>
-              <a:t>Слава Тобі (хай лунає всюди),</a:t>
+              <a:t>Слава Тобі,</a:t>
             </a:r>
             <a:endParaRPr lang="en-US" sz="5200" dirty="0"/>
           </a:p>
@@ -3144,7 +3127,7 @@
                 <a:ea typeface="Arial" pitchFamily="34" charset="-122"/>
                 <a:cs typeface="Arial" pitchFamily="34" charset="-120"/>
               </a:rPr>
-              <a:t>За мене Ти (о Ісусе любий),</a:t>
+              <a:t>За мене Ти,</a:t>
             </a:r>
             <a:endParaRPr lang="en-US" sz="5200" dirty="0"/>
           </a:p>
@@ -3178,7 +3161,7 @@
                 <a:ea typeface="Arial" pitchFamily="34" charset="-122"/>
                 <a:cs typeface="Arial" pitchFamily="34" charset="-120"/>
               </a:rPr>
-              <a:t>Слава Тобі (хай лунає всюди),</a:t>
+              <a:t>Слава Тобі,</a:t>
             </a:r>
             <a:endParaRPr lang="en-US" sz="5200" dirty="0"/>
           </a:p>

</xml_diff>